<commit_message>
Atualiza README, dicionário, model card, roteiro e apresentação
Co-Authored-By: Claude Opus 5.5 <noreply@anthropic.com>
</commit_message>
<xml_diff>
--- a/reports/apresentacao_nps_preditivo.pptx
+++ b/reports/apresentacao_nps_preditivo.pptx
@@ -123,18 +123,18 @@
   <p:extLst>
     <p:ext uri="{521415D9-36F7-43E2-AB2F-B90AF26B5E84}">
       <p14:sectionLst xmlns:p14="http://schemas.microsoft.com/office/powerpoint/2010/main">
-        <p14:section name="Abertura" id="{172df8c1-66f6-9c0f-c663-bf12225434ce}">
+        <p14:section name="Abertura" id="{20639be9-0225-74a3-e90c-72a69f9d7a55}">
           <p14:sldIdLst>
             <p14:sldId id="256"/>
           </p14:sldIdLst>
         </p14:section>
-        <p14:section name="Contexto" id="{aeb5710b-7c90-c618-2cc1-e5c423b581cd}">
+        <p14:section name="Contexto" id="{a28539a5-8f23-5e63-74b9-9b670cf2ba57}">
           <p14:sldIdLst>
             <p14:sldId id="257"/>
             <p14:sldId id="258"/>
           </p14:sldIdLst>
         </p14:section>
-        <p14:section name="Insights" id="{e98e8e3a-7a70-96b0-3f22-9af6c0eece8e}">
+        <p14:section name="Insights" id="{957d0d4a-fcb3-591e-ca86-35664bb3ae51}">
           <p14:sldIdLst>
             <p14:sldId id="259"/>
             <p14:sldId id="260"/>
@@ -145,20 +145,20 @@
             <p14:sldId id="265"/>
           </p14:sldIdLst>
         </p14:section>
-        <p14:section name="Modelo" id="{92df5fa0-1ecc-dc97-c8f1-150f9e428bf0}">
+        <p14:section name="Modelo" id="{a39c0f97-788d-c7cf-350f-6bb0d499ea09}">
           <p14:sldIdLst>
             <p14:sldId id="266"/>
             <p14:sldId id="267"/>
             <p14:sldId id="268"/>
           </p14:sldIdLst>
         </p14:section>
-        <p14:section name="Recomendações" id="{1e5f4a8e-4db7-2fa6-02e2-5391fc7c687c}">
+        <p14:section name="Recomendações" id="{746b0c4a-e9e1-afc4-542f-6864c6ec715a}">
           <p14:sldIdLst>
             <p14:sldId id="269"/>
             <p14:sldId id="270"/>
           </p14:sldIdLst>
         </p14:section>
-        <p14:section name="Encerramento" id="{b8e780c0-d112-8d2c-0ef6-ff9b2db8d1d6}">
+        <p14:section name="Encerramento" id="{7c2d611c-a30f-cc07-7eaf-849c7cf5ac08}">
           <p14:sldIdLst>
             <p14:sldId id="271"/>
             <p14:sldId id="272"/>
@@ -4862,7 +4862,7 @@
           <a:p>
             <a:r>
               <a:rPr lang="en-US" dirty="0"/>
-              <a:t>O e-commerce cresceu e a experiência ficou desigual. O NPS é coletado só no fim da jornada: quando a nota chega, o atraso e as reclamações já aconteceram. Na base analisada, de 2.500 pedidos, o NPS é -80 e 84% dos clientes são detratores. O problema é estrutural, não exceção.</a:t>
+              <a:t>O e-commerce cresceu e a experiência ficou desigual. O NPS é coletado só no fim da jornada: quando a nota chega, o atraso e as reclamações já aconteceram. Na base analisada, de 2.500 pedidos, o NPS é -80, com margem de erro de cerca de 2 pontos, e 84% dos clientes são detratores. O problema é estrutural, não exceção.</a:t>
             </a:r>
             <a:endParaRPr lang="en-US" dirty="0"/>
           </a:p>
@@ -10146,7 +10146,7 @@
                 <a:ea typeface="Calibri" pitchFamily="34" charset="-122"/>
                 <a:cs typeface="Calibri" pitchFamily="34" charset="-120"/>
               </a:rPr>
-              <a:t>Fila por risco em uma região, com grupo de controle para medir o efeito</a:t>
+              <a:t>Fila por risco em uma região, com teste A/B (grupo de controle) para medir o efeito</a:t>
             </a:r>
             <a:endParaRPr lang="en-US" sz="1400" dirty="0"/>
           </a:p>
@@ -10555,7 +10555,7 @@
                 <a:ea typeface="Calibri" pitchFamily="34" charset="-122"/>
                 <a:cs typeface="Calibri" pitchFamily="34" charset="-120"/>
               </a:rPr>
-              <a:t>Os dados mostram associações. As ações devem ser validadas com grupo de controle antes de escalar.</a:t>
+              <a:t>Os dados mostram associações. As ações devem ser validadas com teste A/B antes de escalar.</a:t>
             </a:r>
             <a:endParaRPr lang="en-US" sz="1400" dirty="0"/>
           </a:p>
@@ -12170,7 +12170,7 @@
                 <a:ea typeface="Calibri" pitchFamily="34" charset="-122"/>
                 <a:cs typeface="Calibri" pitchFamily="34" charset="-120"/>
               </a:rPr>
-              <a:t>é o NPS da base: para cada promotor, há 19 detratores</a:t>
+              <a:t>é o NPS da base (margem de erro: −82 a −78): 19 detratores para cada promotor</a:t>
             </a:r>
             <a:endParaRPr lang="en-US" sz="1500" dirty="0"/>
           </a:p>

</xml_diff>